<commit_message>
dev: yolov11/utils/loss.py: understand losses
</commit_message>
<xml_diff>
--- a/yolov11/doc/network.pptx
+++ b/yolov11/doc/network.pptx
@@ -5,13 +5,14 @@
     <p:sldMasterId id="2147483648" r:id="rId1"/>
   </p:sldMasterIdLst>
   <p:notesMasterIdLst>
-    <p:notesMasterId r:id="rId6"/>
+    <p:notesMasterId r:id="rId7"/>
   </p:notesMasterIdLst>
   <p:sldIdLst>
     <p:sldId id="257" r:id="rId2"/>
     <p:sldId id="258" r:id="rId3"/>
     <p:sldId id="259" r:id="rId4"/>
     <p:sldId id="260" r:id="rId5"/>
+    <p:sldId id="261" r:id="rId6"/>
   </p:sldIdLst>
   <p:sldSz cx="12192000" cy="6858000"/>
   <p:notesSz cx="6858000" cy="9144000"/>
@@ -200,7 +201,7 @@
           <a:p>
             <a:fld id="{CE43482B-AAE2-4D82-BA80-F394E45956FB}" type="datetimeFigureOut">
               <a:rPr lang="en-US" smtClean="0"/>
-              <a:t>10/3/2025</a:t>
+              <a:t>10/22/2025</a:t>
             </a:fld>
             <a:endParaRPr lang="en-US"/>
           </a:p>
@@ -698,7 +699,7 @@
           <a:p>
             <a:fld id="{3A50BF58-CDC9-44CC-810E-826C18F21858}" type="datetimeFigureOut">
               <a:rPr lang="en-US" smtClean="0"/>
-              <a:t>10/3/2025</a:t>
+              <a:t>10/22/2025</a:t>
             </a:fld>
             <a:endParaRPr lang="en-US"/>
           </a:p>
@@ -896,7 +897,7 @@
           <a:p>
             <a:fld id="{3A50BF58-CDC9-44CC-810E-826C18F21858}" type="datetimeFigureOut">
               <a:rPr lang="en-US" smtClean="0"/>
-              <a:t>10/3/2025</a:t>
+              <a:t>10/22/2025</a:t>
             </a:fld>
             <a:endParaRPr lang="en-US"/>
           </a:p>
@@ -1104,7 +1105,7 @@
           <a:p>
             <a:fld id="{3A50BF58-CDC9-44CC-810E-826C18F21858}" type="datetimeFigureOut">
               <a:rPr lang="en-US" smtClean="0"/>
-              <a:t>10/3/2025</a:t>
+              <a:t>10/22/2025</a:t>
             </a:fld>
             <a:endParaRPr lang="en-US"/>
           </a:p>
@@ -1302,7 +1303,7 @@
           <a:p>
             <a:fld id="{3A50BF58-CDC9-44CC-810E-826C18F21858}" type="datetimeFigureOut">
               <a:rPr lang="en-US" smtClean="0"/>
-              <a:t>10/3/2025</a:t>
+              <a:t>10/22/2025</a:t>
             </a:fld>
             <a:endParaRPr lang="en-US"/>
           </a:p>
@@ -1577,7 +1578,7 @@
           <a:p>
             <a:fld id="{3A50BF58-CDC9-44CC-810E-826C18F21858}" type="datetimeFigureOut">
               <a:rPr lang="en-US" smtClean="0"/>
-              <a:t>10/3/2025</a:t>
+              <a:t>10/22/2025</a:t>
             </a:fld>
             <a:endParaRPr lang="en-US"/>
           </a:p>
@@ -1842,7 +1843,7 @@
           <a:p>
             <a:fld id="{3A50BF58-CDC9-44CC-810E-826C18F21858}" type="datetimeFigureOut">
               <a:rPr lang="en-US" smtClean="0"/>
-              <a:t>10/3/2025</a:t>
+              <a:t>10/22/2025</a:t>
             </a:fld>
             <a:endParaRPr lang="en-US"/>
           </a:p>
@@ -2254,7 +2255,7 @@
           <a:p>
             <a:fld id="{3A50BF58-CDC9-44CC-810E-826C18F21858}" type="datetimeFigureOut">
               <a:rPr lang="en-US" smtClean="0"/>
-              <a:t>10/3/2025</a:t>
+              <a:t>10/22/2025</a:t>
             </a:fld>
             <a:endParaRPr lang="en-US"/>
           </a:p>
@@ -2395,7 +2396,7 @@
           <a:p>
             <a:fld id="{3A50BF58-CDC9-44CC-810E-826C18F21858}" type="datetimeFigureOut">
               <a:rPr lang="en-US" smtClean="0"/>
-              <a:t>10/3/2025</a:t>
+              <a:t>10/22/2025</a:t>
             </a:fld>
             <a:endParaRPr lang="en-US"/>
           </a:p>
@@ -2508,7 +2509,7 @@
           <a:p>
             <a:fld id="{3A50BF58-CDC9-44CC-810E-826C18F21858}" type="datetimeFigureOut">
               <a:rPr lang="en-US" smtClean="0"/>
-              <a:t>10/3/2025</a:t>
+              <a:t>10/22/2025</a:t>
             </a:fld>
             <a:endParaRPr lang="en-US"/>
           </a:p>
@@ -2819,7 +2820,7 @@
           <a:p>
             <a:fld id="{3A50BF58-CDC9-44CC-810E-826C18F21858}" type="datetimeFigureOut">
               <a:rPr lang="en-US" smtClean="0"/>
-              <a:t>10/3/2025</a:t>
+              <a:t>10/22/2025</a:t>
             </a:fld>
             <a:endParaRPr lang="en-US"/>
           </a:p>
@@ -3107,7 +3108,7 @@
           <a:p>
             <a:fld id="{3A50BF58-CDC9-44CC-810E-826C18F21858}" type="datetimeFigureOut">
               <a:rPr lang="en-US" smtClean="0"/>
-              <a:t>10/3/2025</a:t>
+              <a:t>10/22/2025</a:t>
             </a:fld>
             <a:endParaRPr lang="en-US"/>
           </a:p>
@@ -3348,7 +3349,7 @@
           <a:p>
             <a:fld id="{3A50BF58-CDC9-44CC-810E-826C18F21858}" type="datetimeFigureOut">
               <a:rPr lang="en-US" smtClean="0"/>
-              <a:t>10/3/2025</a:t>
+              <a:t>10/22/2025</a:t>
             </a:fld>
             <a:endParaRPr lang="en-US"/>
           </a:p>
@@ -11464,6 +11465,593 @@
 </p:sld>
 </file>
 
+<file path=ppt/slides/slide5.xml><?xml version="1.0" encoding="utf-8"?>
+<p:sld xmlns:a="http://schemas.openxmlformats.org/drawingml/2006/main" xmlns:r="http://schemas.openxmlformats.org/officeDocument/2006/relationships" xmlns:p="http://schemas.openxmlformats.org/presentationml/2006/main">
+  <p:cSld>
+    <p:spTree>
+      <p:nvGrpSpPr>
+        <p:cNvPr id="1" name=""/>
+        <p:cNvGrpSpPr/>
+        <p:nvPr/>
+      </p:nvGrpSpPr>
+      <p:grpSpPr>
+        <a:xfrm>
+          <a:off x="0" y="0"/>
+          <a:ext cx="0" cy="0"/>
+          <a:chOff x="0" y="0"/>
+          <a:chExt cx="0" cy="0"/>
+        </a:xfrm>
+      </p:grpSpPr>
+      <p:sp>
+        <p:nvSpPr>
+          <p:cNvPr id="2" name="Title 1">
+            <a:extLst>
+              <a:ext uri="{FF2B5EF4-FFF2-40B4-BE49-F238E27FC236}">
+                <a16:creationId xmlns:a16="http://schemas.microsoft.com/office/drawing/2014/main" id="{614ABE1B-01D5-1492-554A-643C6638B61A}"/>
+              </a:ext>
+            </a:extLst>
+          </p:cNvPr>
+          <p:cNvSpPr>
+            <a:spLocks noGrp="1"/>
+          </p:cNvSpPr>
+          <p:nvPr>
+            <p:ph type="title"/>
+          </p:nvPr>
+        </p:nvSpPr>
+        <p:spPr/>
+        <p:txBody>
+          <a:bodyPr/>
+          <a:lstStyle/>
+          <a:p>
+            <a:r>
+              <a:rPr lang="en-US" dirty="0" err="1"/>
+              <a:t>DFLoss</a:t>
+            </a:r>
+            <a:endParaRPr lang="en-US" dirty="0"/>
+          </a:p>
+        </p:txBody>
+      </p:sp>
+      <p:cxnSp>
+        <p:nvCxnSpPr>
+          <p:cNvPr id="5" name="Straight Connector 4">
+            <a:extLst>
+              <a:ext uri="{FF2B5EF4-FFF2-40B4-BE49-F238E27FC236}">
+                <a16:creationId xmlns:a16="http://schemas.microsoft.com/office/drawing/2014/main" id="{FF34DD4A-56E9-5F95-C932-AE97B6CFED0B}"/>
+              </a:ext>
+            </a:extLst>
+          </p:cNvPr>
+          <p:cNvCxnSpPr/>
+          <p:nvPr/>
+        </p:nvCxnSpPr>
+        <p:spPr>
+          <a:xfrm flipV="1">
+            <a:off x="838200" y="2690949"/>
+            <a:ext cx="7628708" cy="0"/>
+          </a:xfrm>
+          <a:prstGeom prst="line">
+            <a:avLst/>
+          </a:prstGeom>
+        </p:spPr>
+        <p:style>
+          <a:lnRef idx="2">
+            <a:schemeClr val="accent1"/>
+          </a:lnRef>
+          <a:fillRef idx="0">
+            <a:schemeClr val="accent1"/>
+          </a:fillRef>
+          <a:effectRef idx="1">
+            <a:schemeClr val="accent1"/>
+          </a:effectRef>
+          <a:fontRef idx="minor">
+            <a:schemeClr val="tx1"/>
+          </a:fontRef>
+        </p:style>
+      </p:cxnSp>
+      <p:sp>
+        <p:nvSpPr>
+          <p:cNvPr id="6" name="Oval 5">
+            <a:extLst>
+              <a:ext uri="{FF2B5EF4-FFF2-40B4-BE49-F238E27FC236}">
+                <a16:creationId xmlns:a16="http://schemas.microsoft.com/office/drawing/2014/main" id="{20194AB1-013B-7C74-2499-591BE8002076}"/>
+              </a:ext>
+            </a:extLst>
+          </p:cNvPr>
+          <p:cNvSpPr/>
+          <p:nvPr/>
+        </p:nvSpPr>
+        <p:spPr>
+          <a:xfrm>
+            <a:off x="1477108" y="2614749"/>
+            <a:ext cx="152400" cy="152400"/>
+          </a:xfrm>
+          <a:prstGeom prst="ellipse">
+            <a:avLst/>
+          </a:prstGeom>
+        </p:spPr>
+        <p:style>
+          <a:lnRef idx="2">
+            <a:schemeClr val="accent1">
+              <a:shade val="15000"/>
+            </a:schemeClr>
+          </a:lnRef>
+          <a:fillRef idx="1">
+            <a:schemeClr val="accent1"/>
+          </a:fillRef>
+          <a:effectRef idx="0">
+            <a:schemeClr val="accent1"/>
+          </a:effectRef>
+          <a:fontRef idx="minor">
+            <a:schemeClr val="lt1"/>
+          </a:fontRef>
+        </p:style>
+        <p:txBody>
+          <a:bodyPr rtlCol="0" anchor="ctr"/>
+          <a:lstStyle/>
+          <a:p>
+            <a:pPr algn="ctr"/>
+            <a:endParaRPr lang="en-US"/>
+          </a:p>
+        </p:txBody>
+      </p:sp>
+      <p:sp>
+        <p:nvSpPr>
+          <p:cNvPr id="7" name="Oval 6">
+            <a:extLst>
+              <a:ext uri="{FF2B5EF4-FFF2-40B4-BE49-F238E27FC236}">
+                <a16:creationId xmlns:a16="http://schemas.microsoft.com/office/drawing/2014/main" id="{13A0C92E-570F-66B0-0AE4-49FF5D09485F}"/>
+              </a:ext>
+            </a:extLst>
+          </p:cNvPr>
+          <p:cNvSpPr/>
+          <p:nvPr/>
+        </p:nvSpPr>
+        <p:spPr>
+          <a:xfrm>
+            <a:off x="7455877" y="2614749"/>
+            <a:ext cx="152400" cy="152400"/>
+          </a:xfrm>
+          <a:prstGeom prst="ellipse">
+            <a:avLst/>
+          </a:prstGeom>
+        </p:spPr>
+        <p:style>
+          <a:lnRef idx="2">
+            <a:schemeClr val="accent1">
+              <a:shade val="15000"/>
+            </a:schemeClr>
+          </a:lnRef>
+          <a:fillRef idx="1">
+            <a:schemeClr val="accent1"/>
+          </a:fillRef>
+          <a:effectRef idx="0">
+            <a:schemeClr val="accent1"/>
+          </a:effectRef>
+          <a:fontRef idx="minor">
+            <a:schemeClr val="lt1"/>
+          </a:fontRef>
+        </p:style>
+        <p:txBody>
+          <a:bodyPr rtlCol="0" anchor="ctr"/>
+          <a:lstStyle/>
+          <a:p>
+            <a:pPr algn="ctr"/>
+            <a:endParaRPr lang="en-US"/>
+          </a:p>
+        </p:txBody>
+      </p:sp>
+      <p:sp>
+        <p:nvSpPr>
+          <p:cNvPr id="8" name="Rectangle 7">
+            <a:extLst>
+              <a:ext uri="{FF2B5EF4-FFF2-40B4-BE49-F238E27FC236}">
+                <a16:creationId xmlns:a16="http://schemas.microsoft.com/office/drawing/2014/main" id="{596CAA66-907F-9557-8B56-CEED4F11DB6E}"/>
+              </a:ext>
+            </a:extLst>
+          </p:cNvPr>
+          <p:cNvSpPr/>
+          <p:nvPr/>
+        </p:nvSpPr>
+        <p:spPr>
+          <a:xfrm>
+            <a:off x="3810000" y="2614749"/>
+            <a:ext cx="152400" cy="152397"/>
+          </a:xfrm>
+          <a:prstGeom prst="rect">
+            <a:avLst/>
+          </a:prstGeom>
+        </p:spPr>
+        <p:style>
+          <a:lnRef idx="2">
+            <a:schemeClr val="accent1">
+              <a:shade val="15000"/>
+            </a:schemeClr>
+          </a:lnRef>
+          <a:fillRef idx="1">
+            <a:schemeClr val="accent1"/>
+          </a:fillRef>
+          <a:effectRef idx="0">
+            <a:schemeClr val="accent1"/>
+          </a:effectRef>
+          <a:fontRef idx="minor">
+            <a:schemeClr val="lt1"/>
+          </a:fontRef>
+        </p:style>
+        <p:txBody>
+          <a:bodyPr rtlCol="0" anchor="ctr"/>
+          <a:lstStyle/>
+          <a:p>
+            <a:pPr algn="ctr"/>
+            <a:endParaRPr lang="en-US"/>
+          </a:p>
+        </p:txBody>
+      </p:sp>
+      <p:sp>
+        <p:nvSpPr>
+          <p:cNvPr id="9" name="TextBox 8">
+            <a:extLst>
+              <a:ext uri="{FF2B5EF4-FFF2-40B4-BE49-F238E27FC236}">
+                <a16:creationId xmlns:a16="http://schemas.microsoft.com/office/drawing/2014/main" id="{FC1506BB-6D30-4E95-AD88-887010789C1D}"/>
+              </a:ext>
+            </a:extLst>
+          </p:cNvPr>
+          <p:cNvSpPr txBox="1"/>
+          <p:nvPr/>
+        </p:nvSpPr>
+        <p:spPr>
+          <a:xfrm>
+            <a:off x="885092" y="2098851"/>
+            <a:ext cx="1752600" cy="369332"/>
+          </a:xfrm>
+          <a:prstGeom prst="rect">
+            <a:avLst/>
+          </a:prstGeom>
+          <a:noFill/>
+        </p:spPr>
+        <p:txBody>
+          <a:bodyPr wrap="square" rtlCol="0">
+            <a:spAutoFit/>
+          </a:bodyPr>
+          <a:lstStyle/>
+          <a:p>
+            <a:r>
+              <a:rPr lang="en-US" dirty="0" err="1"/>
+              <a:t>tl</a:t>
+            </a:r>
+            <a:r>
+              <a:rPr lang="en-US" dirty="0"/>
+              <a:t> : closest int</a:t>
+            </a:r>
+          </a:p>
+        </p:txBody>
+      </p:sp>
+      <p:sp>
+        <p:nvSpPr>
+          <p:cNvPr id="10" name="TextBox 9">
+            <a:extLst>
+              <a:ext uri="{FF2B5EF4-FFF2-40B4-BE49-F238E27FC236}">
+                <a16:creationId xmlns:a16="http://schemas.microsoft.com/office/drawing/2014/main" id="{FC92F3AD-0AB5-7722-64B4-AAF965D0998D}"/>
+              </a:ext>
+            </a:extLst>
+          </p:cNvPr>
+          <p:cNvSpPr txBox="1"/>
+          <p:nvPr/>
+        </p:nvSpPr>
+        <p:spPr>
+          <a:xfrm>
+            <a:off x="7227277" y="2134034"/>
+            <a:ext cx="1752600" cy="369332"/>
+          </a:xfrm>
+          <a:prstGeom prst="rect">
+            <a:avLst/>
+          </a:prstGeom>
+          <a:noFill/>
+        </p:spPr>
+        <p:txBody>
+          <a:bodyPr wrap="square" rtlCol="0">
+            <a:spAutoFit/>
+          </a:bodyPr>
+          <a:lstStyle/>
+          <a:p>
+            <a:r>
+              <a:rPr lang="en-US" dirty="0"/>
+              <a:t>tr=tl+1</a:t>
+            </a:r>
+          </a:p>
+        </p:txBody>
+      </p:sp>
+      <p:sp>
+        <p:nvSpPr>
+          <p:cNvPr id="11" name="TextBox 10">
+            <a:extLst>
+              <a:ext uri="{FF2B5EF4-FFF2-40B4-BE49-F238E27FC236}">
+                <a16:creationId xmlns:a16="http://schemas.microsoft.com/office/drawing/2014/main" id="{F2DC752B-37A4-7CC3-D33C-D8ABC62819C5}"/>
+              </a:ext>
+            </a:extLst>
+          </p:cNvPr>
+          <p:cNvSpPr txBox="1"/>
+          <p:nvPr/>
+        </p:nvSpPr>
+        <p:spPr>
+          <a:xfrm>
+            <a:off x="3464169" y="2128660"/>
+            <a:ext cx="1752600" cy="369332"/>
+          </a:xfrm>
+          <a:prstGeom prst="rect">
+            <a:avLst/>
+          </a:prstGeom>
+          <a:noFill/>
+        </p:spPr>
+        <p:txBody>
+          <a:bodyPr wrap="square" rtlCol="0">
+            <a:spAutoFit/>
+          </a:bodyPr>
+          <a:lstStyle/>
+          <a:p>
+            <a:r>
+              <a:rPr lang="en-US" dirty="0"/>
+              <a:t>target</a:t>
+            </a:r>
+          </a:p>
+        </p:txBody>
+      </p:sp>
+      <p:sp>
+        <p:nvSpPr>
+          <p:cNvPr id="12" name="Right Brace 11">
+            <a:extLst>
+              <a:ext uri="{FF2B5EF4-FFF2-40B4-BE49-F238E27FC236}">
+                <a16:creationId xmlns:a16="http://schemas.microsoft.com/office/drawing/2014/main" id="{BF77E44C-A8B8-940E-442B-A9AD5487B2A8}"/>
+              </a:ext>
+            </a:extLst>
+          </p:cNvPr>
+          <p:cNvSpPr/>
+          <p:nvPr/>
+        </p:nvSpPr>
+        <p:spPr>
+          <a:xfrm rot="5400000">
+            <a:off x="5576892" y="1245196"/>
+            <a:ext cx="264491" cy="3493477"/>
+          </a:xfrm>
+          <a:prstGeom prst="rightBrace">
+            <a:avLst/>
+          </a:prstGeom>
+        </p:spPr>
+        <p:style>
+          <a:lnRef idx="2">
+            <a:schemeClr val="accent1"/>
+          </a:lnRef>
+          <a:fillRef idx="0">
+            <a:schemeClr val="accent1"/>
+          </a:fillRef>
+          <a:effectRef idx="1">
+            <a:schemeClr val="accent1"/>
+          </a:effectRef>
+          <a:fontRef idx="minor">
+            <a:schemeClr val="tx1"/>
+          </a:fontRef>
+        </p:style>
+        <p:txBody>
+          <a:bodyPr rtlCol="0" anchor="ctr"/>
+          <a:lstStyle/>
+          <a:p>
+            <a:pPr algn="ctr"/>
+            <a:endParaRPr lang="en-US"/>
+          </a:p>
+        </p:txBody>
+      </p:sp>
+      <p:sp>
+        <p:nvSpPr>
+          <p:cNvPr id="13" name="TextBox 12">
+            <a:extLst>
+              <a:ext uri="{FF2B5EF4-FFF2-40B4-BE49-F238E27FC236}">
+                <a16:creationId xmlns:a16="http://schemas.microsoft.com/office/drawing/2014/main" id="{D81B51B5-C419-162D-1F00-996986F5DF26}"/>
+              </a:ext>
+            </a:extLst>
+          </p:cNvPr>
+          <p:cNvSpPr txBox="1"/>
+          <p:nvPr/>
+        </p:nvSpPr>
+        <p:spPr>
+          <a:xfrm>
+            <a:off x="5474677" y="3101237"/>
+            <a:ext cx="1752600" cy="369332"/>
+          </a:xfrm>
+          <a:prstGeom prst="rect">
+            <a:avLst/>
+          </a:prstGeom>
+          <a:noFill/>
+        </p:spPr>
+        <p:txBody>
+          <a:bodyPr wrap="square" rtlCol="0">
+            <a:spAutoFit/>
+          </a:bodyPr>
+          <a:lstStyle/>
+          <a:p>
+            <a:r>
+              <a:rPr lang="en-US" dirty="0" err="1"/>
+              <a:t>wl</a:t>
+            </a:r>
+            <a:r>
+              <a:rPr lang="en-US" dirty="0"/>
+              <a:t>=tr-target</a:t>
+            </a:r>
+          </a:p>
+        </p:txBody>
+      </p:sp>
+      <p:sp>
+        <p:nvSpPr>
+          <p:cNvPr id="14" name="Right Brace 13">
+            <a:extLst>
+              <a:ext uri="{FF2B5EF4-FFF2-40B4-BE49-F238E27FC236}">
+                <a16:creationId xmlns:a16="http://schemas.microsoft.com/office/drawing/2014/main" id="{85313A17-E4ED-0D5A-6821-7248C43D28A2}"/>
+              </a:ext>
+            </a:extLst>
+          </p:cNvPr>
+          <p:cNvSpPr/>
+          <p:nvPr/>
+        </p:nvSpPr>
+        <p:spPr>
+          <a:xfrm rot="16200000" flipV="1">
+            <a:off x="4307441" y="-1095981"/>
+            <a:ext cx="388439" cy="5908429"/>
+          </a:xfrm>
+          <a:prstGeom prst="rightBrace">
+            <a:avLst/>
+          </a:prstGeom>
+        </p:spPr>
+        <p:style>
+          <a:lnRef idx="2">
+            <a:schemeClr val="accent1"/>
+          </a:lnRef>
+          <a:fillRef idx="0">
+            <a:schemeClr val="accent1"/>
+          </a:fillRef>
+          <a:effectRef idx="1">
+            <a:schemeClr val="accent1"/>
+          </a:effectRef>
+          <a:fontRef idx="minor">
+            <a:schemeClr val="tx1"/>
+          </a:fontRef>
+        </p:style>
+        <p:txBody>
+          <a:bodyPr rtlCol="0" anchor="ctr"/>
+          <a:lstStyle/>
+          <a:p>
+            <a:pPr algn="ctr"/>
+            <a:endParaRPr lang="en-US"/>
+          </a:p>
+        </p:txBody>
+      </p:sp>
+      <p:sp>
+        <p:nvSpPr>
+          <p:cNvPr id="16" name="TextBox 15">
+            <a:extLst>
+              <a:ext uri="{FF2B5EF4-FFF2-40B4-BE49-F238E27FC236}">
+                <a16:creationId xmlns:a16="http://schemas.microsoft.com/office/drawing/2014/main" id="{B22BAF3D-93CD-93A2-2F36-B5AB36D1723A}"/>
+              </a:ext>
+            </a:extLst>
+          </p:cNvPr>
+          <p:cNvSpPr txBox="1"/>
+          <p:nvPr/>
+        </p:nvSpPr>
+        <p:spPr>
+          <a:xfrm>
+            <a:off x="4343400" y="1340771"/>
+            <a:ext cx="1752600" cy="369332"/>
+          </a:xfrm>
+          <a:prstGeom prst="rect">
+            <a:avLst/>
+          </a:prstGeom>
+          <a:noFill/>
+        </p:spPr>
+        <p:txBody>
+          <a:bodyPr wrap="square" rtlCol="0">
+            <a:spAutoFit/>
+          </a:bodyPr>
+          <a:lstStyle/>
+          <a:p>
+            <a:r>
+              <a:rPr lang="en-US" dirty="0"/>
+              <a:t>1</a:t>
+            </a:r>
+          </a:p>
+        </p:txBody>
+      </p:sp>
+      <p:sp>
+        <p:nvSpPr>
+          <p:cNvPr id="17" name="Right Brace 16">
+            <a:extLst>
+              <a:ext uri="{FF2B5EF4-FFF2-40B4-BE49-F238E27FC236}">
+                <a16:creationId xmlns:a16="http://schemas.microsoft.com/office/drawing/2014/main" id="{C2EC0063-00CE-2F9F-E12F-3D5A5A7C18ED}"/>
+              </a:ext>
+            </a:extLst>
+          </p:cNvPr>
+          <p:cNvSpPr/>
+          <p:nvPr/>
+        </p:nvSpPr>
+        <p:spPr>
+          <a:xfrm rot="5400000">
+            <a:off x="2578427" y="1857934"/>
+            <a:ext cx="200591" cy="2262554"/>
+          </a:xfrm>
+          <a:prstGeom prst="rightBrace">
+            <a:avLst/>
+          </a:prstGeom>
+        </p:spPr>
+        <p:style>
+          <a:lnRef idx="2">
+            <a:schemeClr val="accent1"/>
+          </a:lnRef>
+          <a:fillRef idx="0">
+            <a:schemeClr val="accent1"/>
+          </a:fillRef>
+          <a:effectRef idx="1">
+            <a:schemeClr val="accent1"/>
+          </a:effectRef>
+          <a:fontRef idx="minor">
+            <a:schemeClr val="tx1"/>
+          </a:fontRef>
+        </p:style>
+        <p:txBody>
+          <a:bodyPr rtlCol="0" anchor="ctr"/>
+          <a:lstStyle/>
+          <a:p>
+            <a:pPr algn="ctr"/>
+            <a:endParaRPr lang="en-US"/>
+          </a:p>
+        </p:txBody>
+      </p:sp>
+      <p:sp>
+        <p:nvSpPr>
+          <p:cNvPr id="18" name="TextBox 17">
+            <a:extLst>
+              <a:ext uri="{FF2B5EF4-FFF2-40B4-BE49-F238E27FC236}">
+                <a16:creationId xmlns:a16="http://schemas.microsoft.com/office/drawing/2014/main" id="{9ABF64FF-849A-6108-E6DD-6E8B441FD61C}"/>
+              </a:ext>
+            </a:extLst>
+          </p:cNvPr>
+          <p:cNvSpPr txBox="1"/>
+          <p:nvPr/>
+        </p:nvSpPr>
+        <p:spPr>
+          <a:xfrm>
+            <a:off x="1981200" y="3089507"/>
+            <a:ext cx="1752600" cy="369332"/>
+          </a:xfrm>
+          <a:prstGeom prst="rect">
+            <a:avLst/>
+          </a:prstGeom>
+          <a:noFill/>
+        </p:spPr>
+        <p:txBody>
+          <a:bodyPr wrap="square" rtlCol="0">
+            <a:spAutoFit/>
+          </a:bodyPr>
+          <a:lstStyle/>
+          <a:p>
+            <a:r>
+              <a:rPr lang="en-US" dirty="0" err="1"/>
+              <a:t>wr</a:t>
+            </a:r>
+            <a:r>
+              <a:rPr lang="en-US" dirty="0"/>
+              <a:t>=1-wl</a:t>
+            </a:r>
+          </a:p>
+        </p:txBody>
+      </p:sp>
+    </p:spTree>
+    <p:extLst>
+      <p:ext uri="{BB962C8B-B14F-4D97-AF65-F5344CB8AC3E}">
+        <p14:creationId xmlns:p14="http://schemas.microsoft.com/office/powerpoint/2010/main" val="249187770"/>
+      </p:ext>
+    </p:extLst>
+  </p:cSld>
+  <p:clrMapOvr>
+    <a:masterClrMapping/>
+  </p:clrMapOvr>
+</p:sld>
+</file>
+
 <file path=ppt/theme/theme1.xml><?xml version="1.0" encoding="utf-8"?>
 <a:theme xmlns:a="http://schemas.openxmlformats.org/drawingml/2006/main" name="Office Theme">
   <a:themeElements>

</xml_diff>